<commit_message>
Meer namen op de projectcontext
</commit_message>
<xml_diff>
--- a/static/documents/Projectomgeving FTV.pptx
+++ b/static/documents/Projectomgeving FTV.pptx
@@ -104,6 +104,11 @@
       </a:defRPr>
     </a:lvl9pPr>
   </p:defaultTextStyle>
+  <p:extLst>
+    <p:ext uri="{EFAFB233-063F-42B5-8137-9DF3F51BA10A}">
+      <p15:sldGuideLst xmlns:p15="http://schemas.microsoft.com/office/powerpoint/2012/main"/>
+    </p:ext>
+  </p:extLst>
 </p:presentation>
 </file>
 
@@ -254,7 +259,7 @@
           <a:p>
             <a:fld id="{5698F821-C04C-9A49-A18E-ED1F3CC2D431}" type="datetimeFigureOut">
               <a:rPr lang="nl-NL" smtClean="0"/>
-              <a:t>07-07-2026</a:t>
+              <a:t>08-07-2026</a:t>
             </a:fld>
             <a:endParaRPr lang="nl-NL"/>
           </a:p>
@@ -452,7 +457,7 @@
           <a:p>
             <a:fld id="{5698F821-C04C-9A49-A18E-ED1F3CC2D431}" type="datetimeFigureOut">
               <a:rPr lang="nl-NL" smtClean="0"/>
-              <a:t>07-07-2026</a:t>
+              <a:t>08-07-2026</a:t>
             </a:fld>
             <a:endParaRPr lang="nl-NL"/>
           </a:p>
@@ -660,7 +665,7 @@
           <a:p>
             <a:fld id="{5698F821-C04C-9A49-A18E-ED1F3CC2D431}" type="datetimeFigureOut">
               <a:rPr lang="nl-NL" smtClean="0"/>
-              <a:t>07-07-2026</a:t>
+              <a:t>08-07-2026</a:t>
             </a:fld>
             <a:endParaRPr lang="nl-NL"/>
           </a:p>
@@ -858,7 +863,7 @@
           <a:p>
             <a:fld id="{5698F821-C04C-9A49-A18E-ED1F3CC2D431}" type="datetimeFigureOut">
               <a:rPr lang="nl-NL" smtClean="0"/>
-              <a:t>07-07-2026</a:t>
+              <a:t>08-07-2026</a:t>
             </a:fld>
             <a:endParaRPr lang="nl-NL"/>
           </a:p>
@@ -1133,7 +1138,7 @@
           <a:p>
             <a:fld id="{5698F821-C04C-9A49-A18E-ED1F3CC2D431}" type="datetimeFigureOut">
               <a:rPr lang="nl-NL" smtClean="0"/>
-              <a:t>07-07-2026</a:t>
+              <a:t>08-07-2026</a:t>
             </a:fld>
             <a:endParaRPr lang="nl-NL"/>
           </a:p>
@@ -1398,7 +1403,7 @@
           <a:p>
             <a:fld id="{5698F821-C04C-9A49-A18E-ED1F3CC2D431}" type="datetimeFigureOut">
               <a:rPr lang="nl-NL" smtClean="0"/>
-              <a:t>07-07-2026</a:t>
+              <a:t>08-07-2026</a:t>
             </a:fld>
             <a:endParaRPr lang="nl-NL"/>
           </a:p>
@@ -1810,7 +1815,7 @@
           <a:p>
             <a:fld id="{5698F821-C04C-9A49-A18E-ED1F3CC2D431}" type="datetimeFigureOut">
               <a:rPr lang="nl-NL" smtClean="0"/>
-              <a:t>07-07-2026</a:t>
+              <a:t>08-07-2026</a:t>
             </a:fld>
             <a:endParaRPr lang="nl-NL"/>
           </a:p>
@@ -1951,7 +1956,7 @@
           <a:p>
             <a:fld id="{5698F821-C04C-9A49-A18E-ED1F3CC2D431}" type="datetimeFigureOut">
               <a:rPr lang="nl-NL" smtClean="0"/>
-              <a:t>07-07-2026</a:t>
+              <a:t>08-07-2026</a:t>
             </a:fld>
             <a:endParaRPr lang="nl-NL"/>
           </a:p>
@@ -2064,7 +2069,7 @@
           <a:p>
             <a:fld id="{5698F821-C04C-9A49-A18E-ED1F3CC2D431}" type="datetimeFigureOut">
               <a:rPr lang="nl-NL" smtClean="0"/>
-              <a:t>07-07-2026</a:t>
+              <a:t>08-07-2026</a:t>
             </a:fld>
             <a:endParaRPr lang="nl-NL"/>
           </a:p>
@@ -2375,7 +2380,7 @@
           <a:p>
             <a:fld id="{5698F821-C04C-9A49-A18E-ED1F3CC2D431}" type="datetimeFigureOut">
               <a:rPr lang="nl-NL" smtClean="0"/>
-              <a:t>07-07-2026</a:t>
+              <a:t>08-07-2026</a:t>
             </a:fld>
             <a:endParaRPr lang="nl-NL"/>
           </a:p>
@@ -2663,7 +2668,7 @@
           <a:p>
             <a:fld id="{5698F821-C04C-9A49-A18E-ED1F3CC2D431}" type="datetimeFigureOut">
               <a:rPr lang="nl-NL" smtClean="0"/>
-              <a:t>07-07-2026</a:t>
+              <a:t>08-07-2026</a:t>
             </a:fld>
             <a:endParaRPr lang="nl-NL"/>
           </a:p>
@@ -2904,7 +2909,7 @@
           <a:p>
             <a:fld id="{5698F821-C04C-9A49-A18E-ED1F3CC2D431}" type="datetimeFigureOut">
               <a:rPr lang="nl-NL" smtClean="0"/>
-              <a:t>07-07-2026</a:t>
+              <a:t>08-07-2026</a:t>
             </a:fld>
             <a:endParaRPr lang="nl-NL"/>
           </a:p>
@@ -3415,14 +3420,7 @@
             <a:pPr algn="ctr"/>
             <a:r>
               <a:rPr lang="nl-NL" sz="1400" dirty="0"/>
-              <a:t>PO: Jan Verbeek</a:t>
-            </a:r>
-          </a:p>
-          <a:p>
-            <a:pPr algn="ctr"/>
-            <a:r>
-              <a:rPr lang="nl-NL" sz="1400" dirty="0"/>
-              <a:t>Architect Ilja </a:t>
+              <a:t>PO: Jan Verbeek, Architect Ilja </a:t>
             </a:r>
             <a:r>
               <a:rPr lang="nl-NL" sz="1400" dirty="0" err="1"/>
@@ -3485,8 +3483,12 @@
             <a:pPr algn="ctr"/>
             <a:r>
               <a:rPr lang="nl-NL" sz="1400" b="1" dirty="0"/>
-              <a:t>Project “FTV”</a:t>
-            </a:r>
+              <a:t>Project FTV</a:t>
+            </a:r>
+          </a:p>
+          <a:p>
+            <a:pPr algn="ctr"/>
+            <a:endParaRPr lang="nl-NL" sz="1400" b="1" dirty="0"/>
           </a:p>
           <a:p>
             <a:pPr algn="ctr"/>
@@ -3614,7 +3616,7 @@
             </a:pPr>
             <a:r>
               <a:rPr lang="nl-NL" sz="1400" dirty="0"/>
-              <a:t>Uitdragen / helpen implementatie</a:t>
+              <a:t>Uitdragen / helpen implementaties</a:t>
             </a:r>
           </a:p>
         </p:txBody>
@@ -3676,7 +3678,20 @@
             </a:r>
             <a:r>
               <a:rPr lang="nl-NL" sz="1400" dirty="0"/>
-              <a:t> live bij Utrecht</a:t>
+              <a:t> productiewaardig</a:t>
+            </a:r>
+          </a:p>
+          <a:p>
+            <a:pPr marL="342900" indent="-342900" algn="ctr">
+              <a:buAutoNum type="arabicPeriod"/>
+            </a:pPr>
+            <a:r>
+              <a:rPr lang="nl-NL" sz="1400" dirty="0" err="1"/>
+              <a:t>OpenFTV</a:t>
+            </a:r>
+            <a:r>
+              <a:rPr lang="nl-NL" sz="1400" dirty="0"/>
+              <a:t> live bij Utrecht en Den Haag</a:t>
             </a:r>
           </a:p>
           <a:p>
@@ -3842,8 +3857,8 @@
         </p:nvSpPr>
         <p:spPr>
           <a:xfrm>
-            <a:off x="3496406" y="3578467"/>
-            <a:ext cx="2793026" cy="1916723"/>
+            <a:off x="3409357" y="3572605"/>
+            <a:ext cx="3291255" cy="1916723"/>
           </a:xfrm>
           <a:prstGeom prst="roundRect">
             <a:avLst/>
@@ -3899,7 +3914,22 @@
             </a:r>
             <a:r>
               <a:rPr lang="nl-NL" sz="1400" dirty="0"/>
-              <a:t> :Hugo Stijns, Pim, Henk van Manen</a:t>
+              <a:t> :Hugo Stijns, Pim </a:t>
+            </a:r>
+            <a:r>
+              <a:rPr lang="nl-NL" sz="1400" dirty="0" err="1"/>
+              <a:t>Gaemers</a:t>
+            </a:r>
+            <a:r>
+              <a:rPr lang="nl-NL" sz="1400" dirty="0"/>
+              <a:t>, Henk van Manen</a:t>
+            </a:r>
+          </a:p>
+          <a:p>
+            <a:pPr algn="ctr"/>
+            <a:r>
+              <a:rPr lang="nl-NL" sz="1400" dirty="0"/>
+              <a:t>Architectuur Gideon Zegwaard, Danny Greefhorst </a:t>
             </a:r>
           </a:p>
         </p:txBody>
@@ -3976,8 +4006,8 @@
         </p:nvSpPr>
         <p:spPr>
           <a:xfrm>
-            <a:off x="3496406" y="5556736"/>
-            <a:ext cx="2793026" cy="1005252"/>
+            <a:off x="3409356" y="5568243"/>
+            <a:ext cx="3291255" cy="1005252"/>
           </a:xfrm>
           <a:prstGeom prst="roundRect">
             <a:avLst/>
@@ -4011,11 +4041,35 @@
             <a:pPr algn="ctr"/>
             <a:r>
               <a:rPr lang="nl-NL" sz="1400" dirty="0"/>
-              <a:t>Voorziening </a:t>
+              <a:t>Beheer </a:t>
             </a:r>
             <a:r>
               <a:rPr lang="nl-NL" sz="1400" dirty="0" err="1"/>
               <a:t>OpenFSC</a:t>
+            </a:r>
+            <a:endParaRPr lang="nl-NL" sz="1400" dirty="0"/>
+          </a:p>
+          <a:p>
+            <a:pPr algn="ctr"/>
+            <a:endParaRPr lang="nl-NL" sz="1400" dirty="0"/>
+          </a:p>
+          <a:p>
+            <a:pPr algn="ctr"/>
+            <a:r>
+              <a:rPr lang="nl-NL" sz="1400" dirty="0"/>
+              <a:t>Lonneke </a:t>
+            </a:r>
+            <a:r>
+              <a:rPr lang="nl-NL" sz="1400" dirty="0" err="1"/>
+              <a:t>Dikmans</a:t>
+            </a:r>
+            <a:r>
+              <a:rPr lang="nl-NL" sz="1400" dirty="0"/>
+              <a:t>, Liam </a:t>
+            </a:r>
+            <a:r>
+              <a:rPr lang="nl-NL" sz="1400" dirty="0" err="1"/>
+              <a:t>Muitjens</a:t>
             </a:r>
             <a:endParaRPr lang="nl-NL" sz="1400" dirty="0"/>
           </a:p>
@@ -4072,6 +4126,38 @@
               <a:rPr lang="nl-NL" sz="1400" dirty="0"/>
               <a:t>Beheer van standaarden</a:t>
             </a:r>
+          </a:p>
+          <a:p>
+            <a:pPr algn="ctr"/>
+            <a:endParaRPr lang="nl-NL" sz="1400" dirty="0"/>
+          </a:p>
+          <a:p>
+            <a:pPr algn="ctr"/>
+            <a:r>
+              <a:rPr lang="nl-NL" sz="1400" dirty="0"/>
+              <a:t>Stas </a:t>
+            </a:r>
+            <a:r>
+              <a:rPr lang="nl-NL" sz="1400" dirty="0" err="1"/>
+              <a:t>Mironov</a:t>
+            </a:r>
+            <a:r>
+              <a:rPr lang="nl-NL" sz="1400" dirty="0"/>
+              <a:t>, </a:t>
+            </a:r>
+            <a:r>
+              <a:rPr lang="nl-NL" sz="1400" dirty="0" err="1"/>
+              <a:t>Nil</a:t>
+            </a:r>
+            <a:r>
+              <a:rPr lang="nl-NL" sz="1400" dirty="0"/>
+              <a:t> </a:t>
+            </a:r>
+            <a:r>
+              <a:rPr lang="nl-NL" sz="1400" dirty="0" err="1"/>
+              <a:t>Barua</a:t>
+            </a:r>
+            <a:endParaRPr lang="nl-NL" sz="1400" dirty="0"/>
           </a:p>
         </p:txBody>
       </p:sp>

</xml_diff>

<commit_message>
Spelfout in Aliza's naam
</commit_message>
<xml_diff>
--- a/static/documents/Projectomgeving FTV.pptx
+++ b/static/documents/Projectomgeving FTV.pptx
@@ -3796,11 +3796,19 @@
             <a:pPr algn="ctr"/>
             <a:r>
               <a:rPr lang="nl-NL" sz="1400" dirty="0"/>
-              <a:t>Portfoliomanagers: Eliza </a:t>
+              <a:t>Portfoliomanagers: </a:t>
             </a:r>
             <a:r>
               <a:rPr lang="nl-NL" sz="1400" dirty="0" err="1"/>
-              <a:t>Takovsky</a:t>
+              <a:t>Aliza</a:t>
+            </a:r>
+            <a:r>
+              <a:rPr lang="nl-NL" sz="1400" dirty="0"/>
+              <a:t> </a:t>
+            </a:r>
+            <a:r>
+              <a:rPr lang="nl-NL" sz="1400" dirty="0" err="1"/>
+              <a:t>Tekofsky</a:t>
             </a:r>
             <a:r>
               <a:rPr lang="nl-NL" sz="1400" dirty="0"/>
@@ -3903,7 +3911,7 @@
             <a:pPr algn="ctr"/>
             <a:r>
               <a:rPr lang="nl-NL" sz="1400" dirty="0"/>
-              <a:t>PL: Edward, Mike Dell</a:t>
+              <a:t>PL: Edward, Mike Dell, Andre van Brussel</a:t>
             </a:r>
           </a:p>
           <a:p>
@@ -4047,6 +4055,14 @@
               <a:rPr lang="nl-NL" sz="1400" dirty="0" err="1"/>
               <a:t>OpenFSC</a:t>
             </a:r>
+            <a:r>
+              <a:rPr lang="nl-NL" sz="1400" dirty="0"/>
+              <a:t> en straks </a:t>
+            </a:r>
+            <a:r>
+              <a:rPr lang="nl-NL" sz="1400" dirty="0" err="1"/>
+              <a:t>OpenFTV</a:t>
+            </a:r>
             <a:endParaRPr lang="nl-NL" sz="1400" dirty="0"/>
           </a:p>
           <a:p>
@@ -4364,13 +4380,16 @@
             <a:pPr algn="ctr"/>
             <a:r>
               <a:rPr lang="nl-NL" sz="1400" dirty="0"/>
-              <a:t>CTO </a:t>
+              <a:t>CTO: </a:t>
             </a:r>
             <a:r>
               <a:rPr lang="nl-NL" sz="1400" dirty="0" err="1"/>
               <a:t>Tahir</a:t>
             </a:r>
-            <a:endParaRPr lang="nl-NL" sz="1400" dirty="0"/>
+            <a:r>
+              <a:rPr lang="nl-NL" sz="1400" dirty="0"/>
+              <a:t> Malik</a:t>
+            </a:r>
           </a:p>
         </p:txBody>
       </p:sp>

</xml_diff>

<commit_message>
Update WeAreFrank ipv Contezza
</commit_message>
<xml_diff>
--- a/static/documents/Projectomgeving FTV.pptx
+++ b/static/documents/Projectomgeving FTV.pptx
@@ -259,7 +259,7 @@
           <a:p>
             <a:fld id="{5698F821-C04C-9A49-A18E-ED1F3CC2D431}" type="datetimeFigureOut">
               <a:rPr lang="nl-NL" smtClean="0"/>
-              <a:t>08-07-2026</a:t>
+              <a:t>06-08-2026</a:t>
             </a:fld>
             <a:endParaRPr lang="nl-NL"/>
           </a:p>
@@ -457,7 +457,7 @@
           <a:p>
             <a:fld id="{5698F821-C04C-9A49-A18E-ED1F3CC2D431}" type="datetimeFigureOut">
               <a:rPr lang="nl-NL" smtClean="0"/>
-              <a:t>08-07-2026</a:t>
+              <a:t>06-08-2026</a:t>
             </a:fld>
             <a:endParaRPr lang="nl-NL"/>
           </a:p>
@@ -665,7 +665,7 @@
           <a:p>
             <a:fld id="{5698F821-C04C-9A49-A18E-ED1F3CC2D431}" type="datetimeFigureOut">
               <a:rPr lang="nl-NL" smtClean="0"/>
-              <a:t>08-07-2026</a:t>
+              <a:t>06-08-2026</a:t>
             </a:fld>
             <a:endParaRPr lang="nl-NL"/>
           </a:p>
@@ -863,7 +863,7 @@
           <a:p>
             <a:fld id="{5698F821-C04C-9A49-A18E-ED1F3CC2D431}" type="datetimeFigureOut">
               <a:rPr lang="nl-NL" smtClean="0"/>
-              <a:t>08-07-2026</a:t>
+              <a:t>06-08-2026</a:t>
             </a:fld>
             <a:endParaRPr lang="nl-NL"/>
           </a:p>
@@ -1138,7 +1138,7 @@
           <a:p>
             <a:fld id="{5698F821-C04C-9A49-A18E-ED1F3CC2D431}" type="datetimeFigureOut">
               <a:rPr lang="nl-NL" smtClean="0"/>
-              <a:t>08-07-2026</a:t>
+              <a:t>06-08-2026</a:t>
             </a:fld>
             <a:endParaRPr lang="nl-NL"/>
           </a:p>
@@ -1403,7 +1403,7 @@
           <a:p>
             <a:fld id="{5698F821-C04C-9A49-A18E-ED1F3CC2D431}" type="datetimeFigureOut">
               <a:rPr lang="nl-NL" smtClean="0"/>
-              <a:t>08-07-2026</a:t>
+              <a:t>06-08-2026</a:t>
             </a:fld>
             <a:endParaRPr lang="nl-NL"/>
           </a:p>
@@ -1815,7 +1815,7 @@
           <a:p>
             <a:fld id="{5698F821-C04C-9A49-A18E-ED1F3CC2D431}" type="datetimeFigureOut">
               <a:rPr lang="nl-NL" smtClean="0"/>
-              <a:t>08-07-2026</a:t>
+              <a:t>06-08-2026</a:t>
             </a:fld>
             <a:endParaRPr lang="nl-NL"/>
           </a:p>
@@ -1956,7 +1956,7 @@
           <a:p>
             <a:fld id="{5698F821-C04C-9A49-A18E-ED1F3CC2D431}" type="datetimeFigureOut">
               <a:rPr lang="nl-NL" smtClean="0"/>
-              <a:t>08-07-2026</a:t>
+              <a:t>06-08-2026</a:t>
             </a:fld>
             <a:endParaRPr lang="nl-NL"/>
           </a:p>
@@ -2069,7 +2069,7 @@
           <a:p>
             <a:fld id="{5698F821-C04C-9A49-A18E-ED1F3CC2D431}" type="datetimeFigureOut">
               <a:rPr lang="nl-NL" smtClean="0"/>
-              <a:t>08-07-2026</a:t>
+              <a:t>06-08-2026</a:t>
             </a:fld>
             <a:endParaRPr lang="nl-NL"/>
           </a:p>
@@ -2380,7 +2380,7 @@
           <a:p>
             <a:fld id="{5698F821-C04C-9A49-A18E-ED1F3CC2D431}" type="datetimeFigureOut">
               <a:rPr lang="nl-NL" smtClean="0"/>
-              <a:t>08-07-2026</a:t>
+              <a:t>06-08-2026</a:t>
             </a:fld>
             <a:endParaRPr lang="nl-NL"/>
           </a:p>
@@ -2668,7 +2668,7 @@
           <a:p>
             <a:fld id="{5698F821-C04C-9A49-A18E-ED1F3CC2D431}" type="datetimeFigureOut">
               <a:rPr lang="nl-NL" smtClean="0"/>
-              <a:t>08-07-2026</a:t>
+              <a:t>06-08-2026</a:t>
             </a:fld>
             <a:endParaRPr lang="nl-NL"/>
           </a:p>
@@ -2909,7 +2909,7 @@
           <a:p>
             <a:fld id="{5698F821-C04C-9A49-A18E-ED1F3CC2D431}" type="datetimeFigureOut">
               <a:rPr lang="nl-NL" smtClean="0"/>
-              <a:t>08-07-2026</a:t>
+              <a:t>06-08-2026</a:t>
             </a:fld>
             <a:endParaRPr lang="nl-NL"/>
           </a:p>
@@ -3420,13 +3420,8 @@
             <a:pPr algn="ctr"/>
             <a:r>
               <a:rPr lang="nl-NL" sz="1400" dirty="0"/>
-              <a:t>PO: Jan Verbeek, Architect Ilja </a:t>
-            </a:r>
-            <a:r>
-              <a:rPr lang="nl-NL" sz="1400" dirty="0" err="1"/>
-              <a:t>Vorschtenbosch</a:t>
-            </a:r>
-            <a:endParaRPr lang="nl-NL" sz="1400" dirty="0"/>
+              <a:t>PO: Jan Verbeek, Architect Ilja Vorstenbosch</a:t>
+            </a:r>
           </a:p>
           <a:p>
             <a:pPr algn="ctr"/>
@@ -3763,6 +3758,14 @@
             <a:pPr algn="ctr"/>
             <a:r>
               <a:rPr lang="nl-NL" sz="1400" dirty="0"/>
+              <a:t>Simulatieomgeving hosting</a:t>
+            </a:r>
+            <a:endParaRPr lang="nl-NL" sz="1400" b="1" dirty="0"/>
+          </a:p>
+          <a:p>
+            <a:pPr algn="ctr"/>
+            <a:r>
+              <a:rPr lang="nl-NL" sz="1400" dirty="0"/>
               <a:t>Financiering mix </a:t>
             </a:r>
             <a:r>
@@ -3837,17 +3840,6 @@
               <a:t>Thillo</a:t>
             </a:r>
             <a:endParaRPr lang="nl-NL" sz="1400" dirty="0"/>
-          </a:p>
-          <a:p>
-            <a:pPr algn="ctr"/>
-            <a:endParaRPr lang="nl-NL" sz="1400" dirty="0"/>
-          </a:p>
-          <a:p>
-            <a:pPr algn="ctr"/>
-            <a:r>
-              <a:rPr lang="nl-NL" sz="1400" dirty="0"/>
-              <a:t>Simulatieomgeving hosting</a:t>
-            </a:r>
           </a:p>
         </p:txBody>
       </p:sp>
@@ -3893,7 +3885,7 @@
             <a:pPr algn="ctr"/>
             <a:r>
               <a:rPr lang="nl-NL" sz="1400" b="1" dirty="0"/>
-              <a:t>FDS</a:t>
+              <a:t>Federatief Datastelsel</a:t>
             </a:r>
           </a:p>
           <a:p>
@@ -4360,7 +4352,7 @@
             <a:pPr algn="ctr"/>
             <a:r>
               <a:rPr lang="nl-NL" sz="1400" b="1" dirty="0" err="1"/>
-              <a:t>Contezza</a:t>
+              <a:t>WeAreFrank</a:t>
             </a:r>
             <a:endParaRPr lang="nl-NL" sz="1400" b="1" dirty="0"/>
           </a:p>
@@ -4372,23 +4364,18 @@
             </a:r>
             <a:r>
               <a:rPr lang="nl-NL" sz="1400" dirty="0" err="1"/>
-              <a:t>Tezza</a:t>
-            </a:r>
-            <a:endParaRPr lang="nl-NL" sz="1400" dirty="0"/>
+              <a:t>HaalCentraal</a:t>
+            </a:r>
+            <a:r>
+              <a:rPr lang="nl-NL" sz="1400" dirty="0"/>
+              <a:t> client</a:t>
+            </a:r>
           </a:p>
           <a:p>
             <a:pPr algn="ctr"/>
             <a:r>
               <a:rPr lang="nl-NL" sz="1400" dirty="0"/>
-              <a:t>CTO: </a:t>
-            </a:r>
-            <a:r>
-              <a:rPr lang="nl-NL" sz="1400" dirty="0" err="1"/>
-              <a:t>Tahir</a:t>
-            </a:r>
-            <a:r>
-              <a:rPr lang="nl-NL" sz="1400" dirty="0"/>
-              <a:t> Malik</a:t>
+              <a:t>Jeroen van Roosendaal</a:t>
             </a:r>
           </a:p>
         </p:txBody>

</xml_diff>